<commit_message>
Restructure skills: add aidoc-build, aidoc-document-flow/module, aidoc-writing-adr; update and remove deprecated skills
- Add new skills: aidoc-build, aidoc-document-flow, aidoc-document-module, aidoc-writing-adr
- Remove deprecated: aidoc-create, aidoc-create-adr, claude-sync
- Update SKILL.md files for multiple aidoc skills
- Update build-knowledge templates
- Update pptx module files
- Add travel-planner

Co-Authored-By: Claude Opus 4.8 <noreply@anthropic.com>
</commit_message>
<xml_diff>
--- a/pptx/aidoc-introduction.pptx
+++ b/pptx/aidoc-introduction.pptx
@@ -21,6 +21,7 @@
     <p:sldId id="267" r:id="rId14"/>
     <p:sldId id="268" r:id="rId15"/>
     <p:sldId id="269" r:id="rId16"/>
+    <p:sldId id="272" r:id="rId22"/>
     <p:sldId id="270" r:id="rId17"/>
     <p:sldId id="271" r:id="rId18"/>
   </p:sldIdLst>
@@ -2224,7 +2225,7 @@
                 <a:ea typeface="Calibri" pitchFamily="34" charset="-122"/>
                 <a:cs typeface="Calibri" pitchFamily="34" charset="-120"/>
               </a:rPr>
-              <a:t>9 个技能  ·  5 层知识架构</a:t>
+              <a:t>13 个技能  ·  5 层知识架构</a:t>
             </a:r>
             <a:endParaRPr lang="en-US" sz="1300" dirty="0"/>
           </a:p>
@@ -2314,7 +2315,7 @@
                 <a:ea typeface="Georgia" panose="02040502050405090303" pitchFamily="34" charset="-122"/>
                 <a:cs typeface="Georgia" panose="02040502050405090303" pitchFamily="34" charset="-120"/>
               </a:rPr>
-              <a:t>Phase 4: aidoc-knowledge-init</a:t>
+              <a:t>Phase 4: aidoc-knowledge-init (4a+4b)</a:t>
             </a:r>
             <a:endParaRPr lang="en-US" sz="2600" dirty="0"/>
           </a:p>
@@ -2352,7 +2353,7 @@
                 <a:ea typeface="Calibri" pitchFamily="34" charset="-122"/>
                 <a:cs typeface="Calibri" pitchFamily="34" charset="-120"/>
               </a:rPr>
-              <a:t>知识架构骨架 — 对应五层架构的 L1+L2+L3 层</a:t>
+              <a:t>知识架构骨架 — 对应五层架构的 L1+L2+L3+L4 层，拆分为 4a（Skills）+ 4b（Learnings）</a:t>
             </a:r>
             <a:endParaRPr lang="en-US" sz="1400" dirty="0"/>
           </a:p>
@@ -2435,7 +2436,7 @@
                 <a:ea typeface="Calibri" pitchFamily="34" charset="-122"/>
                 <a:cs typeface="Calibri" pitchFamily="34" charset="-120"/>
               </a:rPr>
-              <a:t>构建四维知识目录：L1 领域能力（skills/）、L2 决策记录（adr/）、L3 经验库（learnings/）、知识库（knowledge/）。</a:t>
+              <a:t>构建四维知识目录：L1 领域能力（skills/）、L2 决策记录（adr/）、L3 经验库（learnings/）、L4 知识库（knowledge/）。拆分为 4a skill-init + 4b learnings-init 两阶段。</a:t>
             </a:r>
             <a:endParaRPr lang="en-US" sz="1200" dirty="0"/>
           </a:p>
@@ -2549,7 +2550,7 @@
                 <a:ea typeface="Calibri" pitchFamily="34" charset="-122"/>
                 <a:cs typeface="Calibri" pitchFamily="34" charset="-120"/>
               </a:rPr>
-              <a:t>docs/skills/ — 封装 scripts/Makefile 的可复用操作</a:t>
+              <a:t>docs/skills/ — 4a: aidoc-skill-init 封装可复用操作</a:t>
             </a:r>
             <a:endParaRPr lang="en-US" sz="900" dirty="0"/>
           </a:p>
@@ -2663,7 +2664,7 @@
                 <a:ea typeface="Calibri" pitchFamily="34" charset="-122"/>
                 <a:cs typeface="Calibri" pitchFamily="34" charset="-120"/>
               </a:rPr>
-              <a:t>docs/adr/ — 检测并生成 MADR 格式架构决策</a:t>
+              <a:t>docs/knowledge/decisions/ — 检测并生成 MADR 格式决策</a:t>
             </a:r>
             <a:endParaRPr lang="en-US" sz="900" dirty="0"/>
           </a:p>
@@ -2777,7 +2778,7 @@
                 <a:ea typeface="Calibri" pitchFamily="34" charset="-122"/>
                 <a:cs typeface="Calibri" pitchFamily="34" charset="-120"/>
               </a:rPr>
-              <a:t>docs/learnings/ — LEARNINGS+ERRORS+FEATURE_REQUESTS</a:t>
+              <a:t>docs/learnings/ — 4b: aidoc-learnings-init 初始化三项</a:t>
             </a:r>
             <a:endParaRPr lang="en-US" sz="900" dirty="0"/>
           </a:p>
@@ -2891,7 +2892,7 @@
                 <a:ea typeface="Calibri" pitchFamily="34" charset="-122"/>
                 <a:cs typeface="Calibri" pitchFamily="34" charset="-120"/>
               </a:rPr>
-              <a:t>docs/knowledge/ — 跨模块深层知识（错误处理/测试/可观测性）</a:t>
+              <a:t>docs/knowledge/ — Phase 6 深度构建 C4+Mermaid+ADR</a:t>
             </a:r>
             <a:endParaRPr lang="en-US" sz="900" dirty="0"/>
           </a:p>
@@ -3062,7 +3063,7 @@
                 <a:ea typeface="Consolas" pitchFamily="34" charset="-122"/>
                 <a:cs typeface="Consolas" pitchFamily="34" charset="-120"/>
               </a:rPr>
-              <a:t>→ docs/skills/ + docs/adr/ + docs/learnings/ + docs/knowledge/</a:t>
+              <a:t>→ Phase 4a: docs/skills/ + Phase 4b: docs/learnings/  (知识库由 Phase 6 深度构建)</a:t>
             </a:r>
             <a:endParaRPr lang="en-US" sz="1200" dirty="0"/>
           </a:p>
@@ -4902,7 +4903,7 @@
                 <a:ea typeface="Consolas" pitchFamily="34" charset="-122"/>
                 <a:cs typeface="Consolas" pitchFamily="34" charset="-120"/>
               </a:rPr>
-              <a:t>→ docs/adr/NNNN-title.md  |  命名: adr-0001-数据库选型.md  |  MADR 2.1.2</a:t>
+              <a:t>→ docs/knowledge/decisions/NNNN-title.md  |  命名: adr-0001-数据库选型.md  |  MADR 2.1.2</a:t>
             </a:r>
             <a:endParaRPr lang="en-US" sz="1100" dirty="0"/>
           </a:p>
@@ -7622,7 +7623,7 @@
                 <a:ea typeface="Georgia" panose="02040502050405090303" pitchFamily="34" charset="-122"/>
                 <a:cs typeface="Georgia" panose="02040502050405090303" pitchFamily="34" charset="-120"/>
               </a:rPr>
-              <a:t>aidoc-create — 主流程编排器</a:t>
+              <a:t>aidoc-build — 主流程编排器</a:t>
             </a:r>
             <a:endParaRPr lang="en-US" sz="3000" dirty="0"/>
           </a:p>
@@ -7660,7 +7661,7 @@
                 <a:ea typeface="Calibri" pitchFamily="34" charset="-122"/>
                 <a:cs typeface="Calibri" pitchFamily="34" charset="-120"/>
               </a:rPr>
-              <a:t>一键串联 Phase 0–5，交互式确认 + 幂等安全 + 数据驱动</a:t>
+              <a:t>一键串联 Phase 0–6，交互式确认 + 幂等安全 + 数据驱动</a:t>
             </a:r>
             <a:endParaRPr lang="en-US" sz="1400" dirty="0"/>
           </a:p>
@@ -8956,7 +8957,7 @@
                 <a:ea typeface="Calibri" pitchFamily="34" charset="-122"/>
                 <a:cs typeface="Calibri" pitchFamily="34" charset="-120"/>
               </a:rPr>
-              <a:t>Phase 0→5 渐进式生成，每阶段确认后再推进，不跳步不覆盖</a:t>
+              <a:t>Phase 0→6 渐进式生成，每阶段确认后再推进，不跳步不覆盖</a:t>
             </a:r>
             <a:endParaRPr lang="en-US" sz="950" dirty="0"/>
           </a:p>
@@ -9273,7 +9274,7 @@
                 <a:ea typeface="Calibri" pitchFamily="34" charset="-122"/>
                 <a:cs typeface="Calibri" pitchFamily="34" charset="-120"/>
               </a:rPr>
-              <a:t>最终产出：AGENTS.md × N + ARCHITECTURE.md + CLAUDE.md + docs/ + .claude/rules/  |  对应五层架构 L0–L4</a:t>
+              <a:t>最终产出：AGENTS.md × N + ARCHITECTURE.md + CLAUDE.md + docs/ + docs/knowledge/ + .claude/rules/  |  对应五层架构 L0–L4</a:t>
             </a:r>
             <a:endParaRPr lang="en-US" sz="1200" dirty="0"/>
           </a:p>
@@ -9540,7 +9541,7 @@
                 <a:ea typeface="Calibri" pitchFamily="34" charset="-122"/>
                 <a:cs typeface="Calibri" pitchFamily="34" charset="-120"/>
               </a:rPr>
-              <a:t>→ 触发 aidoc-create，自动执行 Phase 0-5 全流程，构建 L0-L4 知识架构</a:t>
+              <a:t>→ 触发 aidoc-create，自动执行 Phase 0-6 全流程，构建 L0-L4+ 知识架构</a:t>
             </a:r>
             <a:endParaRPr lang="en-US" sz="1100" dirty="0"/>
           </a:p>
@@ -10055,9 +10056,847 @@
                 <a:ea typeface="Calibri" pitchFamily="34" charset="-122"/>
                 <a:cs typeface="Calibri" pitchFamily="34" charset="-120"/>
               </a:rPr>
-              <a:t>9 个技能  ·  5 个阶段  ·  5 层知识架构  ·  1 套完整的 AI 文档化方案</a:t>
+              <a:t>13 个技能  ·  7 个阶段  ·  5 层知识架构  ·  1 套完整的 AI 文档化方案</a:t>
             </a:r>
             <a:endParaRPr lang="en-US" sz="1500" dirty="0"/>
+          </a:p>
+        </p:txBody>
+      </p:sp>
+    </p:spTree>
+  </p:cSld>
+  <p:clrMapOvr>
+    <a:masterClrMapping/>
+  </p:clrMapOvr>
+</p:sld>
+</file>
+
+<file path=ppt/slides/slide16.xml><?xml version="1.0" encoding="utf-8"?>
+<p:sld xmlns:a="http://schemas.openxmlformats.org/drawingml/2006/main" xmlns:r="http://schemas.openxmlformats.org/officeDocument/2006/relationships" xmlns:p="http://schemas.openxmlformats.org/presentationml/2006/main">
+  <p:cSld>
+    <p:bg>
+      <p:bgPr>
+        <a:solidFill>
+          <a:srgbClr val="FFFFFF"/>
+        </a:solidFill>
+        <a:effectLst/>
+      </p:bgPr>
+    </p:bg>
+    <p:spTree>
+      <p:nvGrpSpPr>
+        <p:cNvPr id="1" name=""/>
+        <p:cNvGrpSpPr/>
+        <p:nvPr/>
+      </p:nvGrpSpPr>
+      <p:grpSpPr>
+        <a:xfrm>
+          <a:off x="0" y="0"/>
+          <a:ext cx="0" cy="0"/>
+          <a:chOff x="0" y="0"/>
+          <a:chExt cx="0" cy="0"/>
+        </a:xfrm>
+      </p:grpSpPr>
+      <p:sp>
+        <p:nvSpPr>
+          <p:cNvPr id="2" name="Shape 0"/>
+          <p:cNvSpPr/>
+          <p:nvPr/>
+        </p:nvSpPr>
+        <p:spPr>
+          <a:xfrm>
+            <a:off x="0" y="0"/>
+            <a:ext cx="73152" cy="5143500"/>
+          </a:xfrm>
+          <a:prstGeom prst="rect">
+            <a:avLst/>
+          </a:prstGeom>
+          <a:solidFill>
+            <a:srgbClr val="EC4899"/>
+          </a:solidFill>
+        </p:spPr>
+      </p:sp>
+      <p:sp>
+        <p:nvSpPr>
+          <p:cNvPr id="3" name="Text 1"/>
+          <p:cNvSpPr/>
+          <p:nvPr/>
+        </p:nvSpPr>
+        <p:spPr>
+          <a:xfrm>
+            <a:off x="640080" y="320040"/>
+            <a:ext cx="7772400" cy="457200"/>
+          </a:xfrm>
+          <a:prstGeom prst="rect">
+            <a:avLst/>
+          </a:prstGeom>
+          <a:noFill/>
+        </p:spPr>
+        <p:txBody>
+          <a:bodyPr wrap="square" lIns="0" tIns="0" rIns="0" bIns="0" rtlCol="0" anchor="ctr"/>
+          <a:lstStyle/>
+          <a:p>
+            <a:pPr marL="0" indent="0">
+              <a:buNone/>
+            </a:pPr>
+            <a:r>
+              <a:rPr lang="en-US" sz="2600" b="1" dirty="0">
+                <a:solidFill>
+                  <a:srgbClr val="0F172A"/>
+                </a:solidFill>
+                <a:latin typeface="Georgia" panose="02040502050405090303" pitchFamily="34" charset="0"/>
+                <a:ea typeface="Georgia" panose="02040502050405090303" pitchFamily="34" charset="-122"/>
+                <a:cs typeface="Georgia" panose="02040502050405090303" pitchFamily="34" charset="-120"/>
+              </a:rPr>
+              <a:t>Phase 6: aidoc-build-knowledge</a:t>
+            </a:r>
+            <a:endParaRPr lang="en-US" sz="2600" dirty="0"/>
+          </a:p>
+        </p:txBody>
+      </p:sp>
+      <p:sp>
+        <p:nvSpPr>
+          <p:cNvPr id="4" name="Text 2"/>
+          <p:cNvSpPr/>
+          <p:nvPr/>
+        </p:nvSpPr>
+        <p:spPr>
+          <a:xfrm>
+            <a:off x="640080" y="749808"/>
+            <a:ext cx="7772400" cy="320040"/>
+          </a:xfrm>
+          <a:prstGeom prst="rect">
+            <a:avLst/>
+          </a:prstGeom>
+          <a:noFill/>
+        </p:spPr>
+        <p:txBody>
+          <a:bodyPr wrap="square" lIns="0" tIns="0" rIns="0" bIns="0" rtlCol="0" anchor="ctr"/>
+          <a:lstStyle/>
+          <a:p>
+            <a:pPr marL="0" indent="0">
+              <a:buNone/>
+            </a:pPr>
+            <a:r>
+              <a:rPr lang="en-US" sz="1400" dirty="0">
+                <a:solidFill>
+                  <a:srgbClr val="EC4899"/>
+                </a:solidFill>
+                <a:latin typeface="Calibri" pitchFamily="34" charset="0"/>
+                <a:ea typeface="Calibri" pitchFamily="34" charset="-122"/>
+                <a:cs typeface="Calibri" pitchFamily="34" charset="-120"/>
+              </a:rPr>
+              <a:t>知识库深度构建 — 基于 C4 模型 + Mermaid + ADR 的研究驱动方案</a:t>
+            </a:r>
+            <a:endParaRPr lang="en-US" sz="1400" dirty="0"/>
+          </a:p>
+        </p:txBody>
+      </p:sp>
+      <p:sp>
+        <p:nvSpPr>
+          <p:cNvPr id="5" name="Shape 3"/>
+          <p:cNvSpPr/>
+          <p:nvPr/>
+        </p:nvSpPr>
+        <p:spPr>
+          <a:xfrm>
+            <a:off x="7772400" y="182880"/>
+            <a:ext cx="777240" cy="777240"/>
+          </a:xfrm>
+          <a:prstGeom prst="rect">
+            <a:avLst/>
+          </a:prstGeom>
+          <a:solidFill>
+            <a:srgbClr val="EC4899">
+              <a:alpha val="12000"/>
+            </a:srgbClr>
+          </a:solidFill>
+        </p:spPr>
+      </p:sp>
+      <p:pic>
+        <p:nvPicPr>
+          <p:cNvPr id="6" name="Image 0" descr="preencoded.png"/>
+          <p:cNvPicPr>
+            <a:picLocks noChangeAspect="1"/>
+          </p:cNvPicPr>
+          <p:nvPr/>
+        </p:nvPicPr>
+        <p:blipFill>
+          <a:blip r:embed="rId1"/>
+          <a:stretch>
+            <a:fillRect/>
+          </a:stretch>
+        </p:blipFill>
+        <p:spPr>
+          <a:xfrm>
+            <a:off x="7863840" y="274320"/>
+            <a:ext cx="594360" cy="594360"/>
+          </a:xfrm>
+          <a:prstGeom prst="rect">
+            <a:avLst/>
+          </a:prstGeom>
+        </p:spPr>
+      </p:pic>
+      <p:sp>
+        <p:nvSpPr>
+          <p:cNvPr id="7" name="Text 4"/>
+          <p:cNvSpPr/>
+          <p:nvPr/>
+        </p:nvSpPr>
+        <p:spPr>
+          <a:xfrm>
+            <a:off x="640080" y="1188720"/>
+            <a:ext cx="7772400" cy="365760"/>
+          </a:xfrm>
+          <a:prstGeom prst="rect">
+            <a:avLst/>
+          </a:prstGeom>
+          <a:noFill/>
+        </p:spPr>
+        <p:txBody>
+          <a:bodyPr wrap="square" lIns="0" tIns="0" rIns="0" bIns="0" rtlCol="0" anchor="ctr"/>
+          <a:lstStyle/>
+          <a:p>
+            <a:pPr marL="0" indent="0">
+              <a:buNone/>
+            </a:pPr>
+            <a:r>
+              <a:rPr lang="en-US" sz="1200" dirty="0">
+                <a:solidFill>
+                  <a:srgbClr val="334155"/>
+                </a:solidFill>
+                <a:latin typeface="Calibri" pitchFamily="34" charset="0"/>
+                <a:ea typeface="Calibri" pitchFamily="34" charset="-122"/>
+                <a:cs typeface="Calibri" pitchFamily="34" charset="-120"/>
+              </a:rPr>
+              <a:t>基于 20+ 来源深度调研（2025-2026），采用业界最佳实践三件套：C4 模型做四层递进架构图、Mermaid 做 Diagram-as-Code 版本控制、MADR 格式 ADR 做决策记录。双轴组织：地图（modules/）+ 路线（flows/），双向超链接关联。</a:t>
+            </a:r>
+            <a:endParaRPr lang="en-US" sz="1200" dirty="0"/>
+          </a:p>
+        </p:txBody>
+      </p:sp>
+      <p:sp>
+        <p:nvSpPr>
+          <p:cNvPr id="8" name="Shape 5"/>
+          <p:cNvSpPr/>
+          <p:nvPr/>
+        </p:nvSpPr>
+        <p:spPr>
+          <a:xfrm>
+            <a:off x="640080" y="1691640"/>
+            <a:ext cx="2697480" cy="594360"/>
+          </a:xfrm>
+          <a:prstGeom prst="rect">
+            <a:avLst/>
+          </a:prstGeom>
+          <a:solidFill>
+            <a:srgbClr val="F8FAFC"/>
+          </a:solidFill>
+        </p:spPr>
+      </p:sp>
+      <p:sp>
+        <p:nvSpPr>
+          <p:cNvPr id="9" name="Shape 6"/>
+          <p:cNvSpPr/>
+          <p:nvPr/>
+        </p:nvSpPr>
+        <p:spPr>
+          <a:xfrm>
+            <a:off x="640080" y="1691640"/>
+            <a:ext cx="45720" cy="594360"/>
+          </a:xfrm>
+          <a:prstGeom prst="rect">
+            <a:avLst/>
+          </a:prstGeom>
+          <a:solidFill>
+            <a:srgbClr val="EC4899"/>
+          </a:solidFill>
+        </p:spPr>
+      </p:sp>
+      <p:sp>
+        <p:nvSpPr>
+          <p:cNvPr id="10" name="Text 7"/>
+          <p:cNvSpPr/>
+          <p:nvPr/>
+        </p:nvSpPr>
+        <p:spPr>
+          <a:xfrm>
+            <a:off x="777240" y="1746504"/>
+            <a:ext cx="2468880" cy="237744"/>
+          </a:xfrm>
+          <a:prstGeom prst="rect">
+            <a:avLst/>
+          </a:prstGeom>
+          <a:noFill/>
+        </p:spPr>
+        <p:txBody>
+          <a:bodyPr wrap="square" lIns="0" tIns="0" rIns="0" bIns="0" rtlCol="0" anchor="ctr"/>
+          <a:lstStyle/>
+          <a:p>
+            <a:pPr marL="0" indent="0">
+              <a:buNone/>
+            </a:pPr>
+            <a:r>
+              <a:rPr lang="en-US" sz="1200" b="1" dirty="0">
+                <a:solidFill>
+                  <a:srgbClr val="0F172A"/>
+                </a:solidFill>
+                <a:latin typeface="Calibri" pitchFamily="34" charset="0"/>
+                <a:ea typeface="Calibri" pitchFamily="34" charset="-122"/>
+                <a:cs typeface="Calibri" pitchFamily="34" charset="-120"/>
+              </a:rPr>
+              <a:t>C4 递进模型</a:t>
+            </a:r>
+            <a:endParaRPr lang="en-US" sz="1200" dirty="0"/>
+          </a:p>
+        </p:txBody>
+      </p:sp>
+      <p:sp>
+        <p:nvSpPr>
+          <p:cNvPr id="11" name="Text 8"/>
+          <p:cNvSpPr/>
+          <p:nvPr/>
+        </p:nvSpPr>
+        <p:spPr>
+          <a:xfrm>
+            <a:off x="777240" y="1984248"/>
+            <a:ext cx="2468880" cy="256032"/>
+          </a:xfrm>
+          <a:prstGeom prst="rect">
+            <a:avLst/>
+          </a:prstGeom>
+          <a:noFill/>
+        </p:spPr>
+        <p:txBody>
+          <a:bodyPr wrap="square" lIns="0" tIns="0" rIns="0" bIns="0" rtlCol="0" anchor="ctr"/>
+          <a:lstStyle/>
+          <a:p>
+            <a:pPr marL="0" indent="0">
+              <a:buNone/>
+            </a:pPr>
+            <a:r>
+              <a:rPr lang="en-US" sz="900" dirty="0">
+                <a:solidFill>
+                  <a:srgbClr val="64748B"/>
+                </a:solidFill>
+                <a:latin typeface="Calibri" pitchFamily="34" charset="0"/>
+                <a:ea typeface="Calibri" pitchFamily="34" charset="-122"/>
+                <a:cs typeface="Calibri" pitchFamily="34" charset="-120"/>
+              </a:rPr>
+              <a:t>四层递进（Context → Container → Component → Code），完美覆盖架构图 + 模块内部架构 + 流程图需求</a:t>
+            </a:r>
+            <a:endParaRPr lang="en-US" sz="900" dirty="0"/>
+          </a:p>
+        </p:txBody>
+      </p:sp>
+      <p:sp>
+        <p:nvSpPr>
+          <p:cNvPr id="12" name="Shape 9"/>
+          <p:cNvSpPr/>
+          <p:nvPr/>
+        </p:nvSpPr>
+        <p:spPr>
+          <a:xfrm>
+            <a:off x="3493008" y="1691640"/>
+            <a:ext cx="2697480" cy="594360"/>
+          </a:xfrm>
+          <a:prstGeom prst="rect">
+            <a:avLst/>
+          </a:prstGeom>
+          <a:solidFill>
+            <a:srgbClr val="F8FAFC"/>
+          </a:solidFill>
+        </p:spPr>
+      </p:sp>
+      <p:sp>
+        <p:nvSpPr>
+          <p:cNvPr id="13" name="Shape 10"/>
+          <p:cNvSpPr/>
+          <p:nvPr/>
+        </p:nvSpPr>
+        <p:spPr>
+          <a:xfrm>
+            <a:off x="3493008" y="1691640"/>
+            <a:ext cx="45720" cy="594360"/>
+          </a:xfrm>
+          <a:prstGeom prst="rect">
+            <a:avLst/>
+          </a:prstGeom>
+          <a:solidFill>
+            <a:srgbClr val="EC4899"/>
+          </a:solidFill>
+        </p:spPr>
+      </p:sp>
+      <p:sp>
+        <p:nvSpPr>
+          <p:cNvPr id="14" name="Text 11"/>
+          <p:cNvSpPr/>
+          <p:nvPr/>
+        </p:nvSpPr>
+        <p:spPr>
+          <a:xfrm>
+            <a:off x="3630168" y="1746504"/>
+            <a:ext cx="2468880" cy="237744"/>
+          </a:xfrm>
+          <a:prstGeom prst="rect">
+            <a:avLst/>
+          </a:prstGeom>
+          <a:noFill/>
+        </p:spPr>
+        <p:txBody>
+          <a:bodyPr wrap="square" lIns="0" tIns="0" rIns="0" bIns="0" rtlCol="0" anchor="ctr"/>
+          <a:lstStyle/>
+          <a:p>
+            <a:pPr marL="0" indent="0">
+              <a:buNone/>
+            </a:pPr>
+            <a:r>
+              <a:rPr lang="en-US" sz="1200" b="1" dirty="0">
+                <a:solidFill>
+                  <a:srgbClr val="0F172A"/>
+                </a:solidFill>
+                <a:latin typeface="Calibri" pitchFamily="34" charset="0"/>
+                <a:ea typeface="Calibri" pitchFamily="34" charset="-122"/>
+                <a:cs typeface="Calibri" pitchFamily="34" charset="-120"/>
+              </a:rPr>
+              <a:t>Mermaid Diagram-as-Code</a:t>
+            </a:r>
+            <a:endParaRPr lang="en-US" sz="1200" dirty="0"/>
+          </a:p>
+        </p:txBody>
+      </p:sp>
+      <p:sp>
+        <p:nvSpPr>
+          <p:cNvPr id="15" name="Text 12"/>
+          <p:cNvSpPr/>
+          <p:nvPr/>
+        </p:nvSpPr>
+        <p:spPr>
+          <a:xfrm>
+            <a:off x="3630168" y="1984248"/>
+            <a:ext cx="2468880" cy="256032"/>
+          </a:xfrm>
+          <a:prstGeom prst="rect">
+            <a:avLst/>
+          </a:prstGeom>
+          <a:noFill/>
+        </p:spPr>
+        <p:txBody>
+          <a:bodyPr wrap="square" lIns="0" tIns="0" rIns="0" bIns="0" rtlCol="0" anchor="ctr"/>
+          <a:lstStyle/>
+          <a:p>
+            <a:pPr marL="0" indent="0">
+              <a:buNone/>
+            </a:pPr>
+            <a:r>
+              <a:rPr lang="en-US" sz="900" dirty="0">
+                <a:solidFill>
+                  <a:srgbClr val="64748B"/>
+                </a:solidFill>
+                <a:latin typeface="Calibri" pitchFamily="34" charset="0"/>
+                <a:ea typeface="Calibri" pitchFamily="34" charset="-122"/>
+                <a:cs typeface="Calibri" pitchFamily="34" charset="-120"/>
+              </a:rPr>
+              <a:t>GitHub/GitLab 原生渲染，零配置，Markdown 嵌入，LLM 生成友好度最优，秒级上手</a:t>
+            </a:r>
+            <a:endParaRPr lang="en-US" sz="900" dirty="0"/>
+          </a:p>
+        </p:txBody>
+      </p:sp>
+      <p:sp>
+        <p:nvSpPr>
+          <p:cNvPr id="16" name="Shape 13"/>
+          <p:cNvSpPr/>
+          <p:nvPr/>
+        </p:nvSpPr>
+        <p:spPr>
+          <a:xfrm>
+            <a:off x="6345936" y="1691640"/>
+            <a:ext cx="2697480" cy="594360"/>
+          </a:xfrm>
+          <a:prstGeom prst="rect">
+            <a:avLst/>
+          </a:prstGeom>
+          <a:solidFill>
+            <a:srgbClr val="F8FAFC"/>
+          </a:solidFill>
+        </p:spPr>
+      </p:sp>
+      <p:sp>
+        <p:nvSpPr>
+          <p:cNvPr id="17" name="Shape 14"/>
+          <p:cNvSpPr/>
+          <p:nvPr/>
+        </p:nvSpPr>
+        <p:spPr>
+          <a:xfrm>
+            <a:off x="6345936" y="1691640"/>
+            <a:ext cx="45720" cy="594360"/>
+          </a:xfrm>
+          <a:prstGeom prst="rect">
+            <a:avLst/>
+          </a:prstGeom>
+          <a:solidFill>
+            <a:srgbClr val="EC4899"/>
+          </a:solidFill>
+        </p:spPr>
+      </p:sp>
+      <p:sp>
+        <p:nvSpPr>
+          <p:cNvPr id="18" name="Text 15"/>
+          <p:cNvSpPr/>
+          <p:nvPr/>
+        </p:nvSpPr>
+        <p:spPr>
+          <a:xfrm>
+            <a:off x="6483096" y="1746504"/>
+            <a:ext cx="2468880" cy="237744"/>
+          </a:xfrm>
+          <a:prstGeom prst="rect">
+            <a:avLst/>
+          </a:prstGeom>
+          <a:noFill/>
+        </p:spPr>
+        <p:txBody>
+          <a:bodyPr wrap="square" lIns="0" tIns="0" rIns="0" bIns="0" rtlCol="0" anchor="ctr"/>
+          <a:lstStyle/>
+          <a:p>
+            <a:pPr marL="0" indent="0">
+              <a:buNone/>
+            </a:pPr>
+            <a:r>
+              <a:rPr lang="en-US" sz="1200" b="1" dirty="0">
+                <a:solidFill>
+                  <a:srgbClr val="0F172A"/>
+                </a:solidFill>
+                <a:latin typeface="Calibri" pitchFamily="34" charset="0"/>
+                <a:ea typeface="Calibri" pitchFamily="34" charset="-122"/>
+                <a:cs typeface="Calibri" pitchFamily="34" charset="-120"/>
+              </a:rPr>
+              <a:t>地图 + 路线双轴</a:t>
+            </a:r>
+            <a:endParaRPr lang="en-US" sz="1200" dirty="0"/>
+          </a:p>
+        </p:txBody>
+      </p:sp>
+      <p:sp>
+        <p:nvSpPr>
+          <p:cNvPr id="19" name="Text 16"/>
+          <p:cNvSpPr/>
+          <p:nvPr/>
+        </p:nvSpPr>
+        <p:spPr>
+          <a:xfrm>
+            <a:off x="6483096" y="1984248"/>
+            <a:ext cx="2468880" cy="256032"/>
+          </a:xfrm>
+          <a:prstGeom prst="rect">
+            <a:avLst/>
+          </a:prstGeom>
+          <a:noFill/>
+        </p:spPr>
+        <p:txBody>
+          <a:bodyPr wrap="square" lIns="0" tIns="0" rIns="0" bIns="0" rtlCol="0" anchor="ctr"/>
+          <a:lstStyle/>
+          <a:p>
+            <a:pPr marL="0" indent="0">
+              <a:buNone/>
+            </a:pPr>
+            <a:r>
+              <a:rPr lang="en-US" sz="900" dirty="0">
+                <a:solidFill>
+                  <a:srgbClr val="64748B"/>
+                </a:solidFill>
+                <a:latin typeface="Calibri" pitchFamily="34" charset="0"/>
+                <a:ea typeface="Calibri" pitchFamily="34" charset="-122"/>
+                <a:cs typeface="Calibri" pitchFamily="34" charset="-120"/>
+              </a:rPr>
+              <a:t>modules/ 承载模块蓝图（C4 Component），flows/ 承载流程蓝图（Mermaid 时序图），双向超链接导航</a:t>
+            </a:r>
+            <a:endParaRPr lang="en-US" sz="900" dirty="0"/>
+          </a:p>
+        </p:txBody>
+      </p:sp>
+      <p:sp>
+        <p:nvSpPr>
+          <p:cNvPr id="20" name="Shape 17"/>
+          <p:cNvSpPr/>
+          <p:nvPr/>
+        </p:nvSpPr>
+        <p:spPr>
+          <a:xfrm>
+            <a:off x="1751076" y="2395728"/>
+            <a:ext cx="2697480" cy="594360"/>
+          </a:xfrm>
+          <a:prstGeom prst="rect">
+            <a:avLst/>
+          </a:prstGeom>
+          <a:solidFill>
+            <a:srgbClr val="F8FAFC"/>
+          </a:solidFill>
+        </p:spPr>
+      </p:sp>
+      <p:sp>
+        <p:nvSpPr>
+          <p:cNvPr id="21" name="Shape 18"/>
+          <p:cNvSpPr/>
+          <p:nvPr/>
+        </p:nvSpPr>
+        <p:spPr>
+          <a:xfrm>
+            <a:off x="1751076" y="2395728"/>
+            <a:ext cx="45720" cy="594360"/>
+          </a:xfrm>
+          <a:prstGeom prst="rect">
+            <a:avLst/>
+          </a:prstGeom>
+          <a:solidFill>
+            <a:srgbClr val="EC4899"/>
+          </a:solidFill>
+        </p:spPr>
+      </p:sp>
+      <p:sp>
+        <p:nvSpPr>
+          <p:cNvPr id="22" name="Text 19"/>
+          <p:cNvSpPr/>
+          <p:nvPr/>
+        </p:nvSpPr>
+        <p:spPr>
+          <a:xfrm>
+            <a:off x="1888236" y="2450592"/>
+            <a:ext cx="2468880" cy="237744"/>
+          </a:xfrm>
+          <a:prstGeom prst="rect">
+            <a:avLst/>
+          </a:prstGeom>
+          <a:noFill/>
+        </p:spPr>
+        <p:txBody>
+          <a:bodyPr wrap="square" lIns="0" tIns="0" rIns="0" bIns="0" rtlCol="0" anchor="ctr"/>
+          <a:lstStyle/>
+          <a:p>
+            <a:pPr marL="0" indent="0">
+              <a:buNone/>
+            </a:pPr>
+            <a:r>
+              <a:rPr lang="en-US" sz="1200" b="1" dirty="0">
+                <a:solidFill>
+                  <a:srgbClr val="0F172A"/>
+                </a:solidFill>
+                <a:latin typeface="Calibri" pitchFamily="34" charset="0"/>
+                <a:ea typeface="Calibri" pitchFamily="34" charset="-122"/>
+                <a:cs typeface="Calibri" pitchFamily="34" charset="-120"/>
+              </a:rPr>
+              <a:t>MADR 格式 ADR</a:t>
+            </a:r>
+            <a:endParaRPr lang="en-US" sz="1200" dirty="0"/>
+          </a:p>
+        </p:txBody>
+      </p:sp>
+      <p:sp>
+        <p:nvSpPr>
+          <p:cNvPr id="23" name="Text 20"/>
+          <p:cNvSpPr/>
+          <p:nvPr/>
+        </p:nvSpPr>
+        <p:spPr>
+          <a:xfrm>
+            <a:off x="1888236" y="2688336"/>
+            <a:ext cx="2468880" cy="256032"/>
+          </a:xfrm>
+          <a:prstGeom prst="rect">
+            <a:avLst/>
+          </a:prstGeom>
+          <a:noFill/>
+        </p:spPr>
+        <p:txBody>
+          <a:bodyPr wrap="square" lIns="0" tIns="0" rIns="0" bIns="0" rtlCol="0" anchor="ctr"/>
+          <a:lstStyle/>
+          <a:p>
+            <a:pPr marL="0" indent="0">
+              <a:buNone/>
+            </a:pPr>
+            <a:r>
+              <a:rPr lang="en-US" sz="900" dirty="0">
+                <a:solidFill>
+                  <a:srgbClr val="64748B"/>
+                </a:solidFill>
+                <a:latin typeface="Calibri" pitchFamily="34" charset="0"/>
+                <a:ea typeface="Calibri" pitchFamily="34" charset="-122"/>
+                <a:cs typeface="Calibri" pitchFamily="34" charset="-120"/>
+              </a:rPr>
+              <a:t>POS/NEG/ALT/IMP/REF 前缀编码，YAML frontmatter，AI 可程序化检索决策，状态追踪生命周期</a:t>
+            </a:r>
+            <a:endParaRPr lang="en-US" sz="900" dirty="0"/>
+          </a:p>
+        </p:txBody>
+      </p:sp>
+      <p:sp>
+        <p:nvSpPr>
+          <p:cNvPr id="24" name="Shape 21"/>
+          <p:cNvSpPr/>
+          <p:nvPr/>
+        </p:nvSpPr>
+        <p:spPr>
+          <a:xfrm>
+            <a:off x="4604004" y="2395728"/>
+            <a:ext cx="2697480" cy="594360"/>
+          </a:xfrm>
+          <a:prstGeom prst="rect">
+            <a:avLst/>
+          </a:prstGeom>
+          <a:solidFill>
+            <a:srgbClr val="F8FAFC"/>
+          </a:solidFill>
+        </p:spPr>
+      </p:sp>
+      <p:sp>
+        <p:nvSpPr>
+          <p:cNvPr id="25" name="Shape 22"/>
+          <p:cNvSpPr/>
+          <p:nvPr/>
+        </p:nvSpPr>
+        <p:spPr>
+          <a:xfrm>
+            <a:off x="4604004" y="2395728"/>
+            <a:ext cx="45720" cy="594360"/>
+          </a:xfrm>
+          <a:prstGeom prst="rect">
+            <a:avLst/>
+          </a:prstGeom>
+          <a:solidFill>
+            <a:srgbClr val="EC4899"/>
+          </a:solidFill>
+        </p:spPr>
+      </p:sp>
+      <p:sp>
+        <p:nvSpPr>
+          <p:cNvPr id="26" name="Text 23"/>
+          <p:cNvSpPr/>
+          <p:nvPr/>
+        </p:nvSpPr>
+        <p:spPr>
+          <a:xfrm>
+            <a:off x="4741164" y="2450592"/>
+            <a:ext cx="2468880" cy="237744"/>
+          </a:xfrm>
+          <a:prstGeom prst="rect">
+            <a:avLst/>
+          </a:prstGeom>
+          <a:noFill/>
+        </p:spPr>
+        <p:txBody>
+          <a:bodyPr wrap="square" lIns="0" tIns="0" rIns="0" bIns="0" rtlCol="0" anchor="ctr"/>
+          <a:lstStyle/>
+          <a:p>
+            <a:pPr marL="0" indent="0">
+              <a:buNone/>
+            </a:pPr>
+            <a:r>
+              <a:rPr lang="en-US" sz="1200" b="1" dirty="0">
+                <a:solidFill>
+                  <a:srgbClr val="0F172A"/>
+                </a:solidFill>
+                <a:latin typeface="Calibri" pitchFamily="34" charset="0"/>
+                <a:ea typeface="Calibri" pitchFamily="34" charset="-122"/>
+                <a:cs typeface="Calibri" pitchFamily="34" charset="-120"/>
+              </a:rPr>
+              <a:t>研究驱动设计</a:t>
+            </a:r>
+            <a:endParaRPr lang="en-US" sz="1200" dirty="0"/>
+          </a:p>
+        </p:txBody>
+      </p:sp>
+      <p:sp>
+        <p:nvSpPr>
+          <p:cNvPr id="27" name="Text 24"/>
+          <p:cNvSpPr/>
+          <p:nvPr/>
+        </p:nvSpPr>
+        <p:spPr>
+          <a:xfrm>
+            <a:off x="4741164" y="2688336"/>
+            <a:ext cx="2468880" cy="256032"/>
+          </a:xfrm>
+          <a:prstGeom prst="rect">
+            <a:avLst/>
+          </a:prstGeom>
+          <a:noFill/>
+        </p:spPr>
+        <p:txBody>
+          <a:bodyPr wrap="square" lIns="0" tIns="0" rIns="0" bIns="0" rtlCol="0" anchor="ctr"/>
+          <a:lstStyle/>
+          <a:p>
+            <a:pPr marL="0" indent="0">
+              <a:buNone/>
+            </a:pPr>
+            <a:r>
+              <a:rPr lang="en-US" sz="900" dirty="0">
+                <a:solidFill>
+                  <a:srgbClr val="64748B"/>
+                </a:solidFill>
+                <a:latin typeface="Calibri" pitchFamily="34" charset="0"/>
+                <a:ea typeface="Calibri" pitchFamily="34" charset="-122"/>
+                <a:cs typeface="Calibri" pitchFamily="34" charset="-120"/>
+              </a:rPr>
+              <a:t>20+ 来源深度调研，8 次 WebSearch + 4 次深度阅读，对标 arc42/LikeC4/Structurizr 等前沿工具</a:t>
+            </a:r>
+            <a:endParaRPr lang="en-US" sz="900" dirty="0"/>
+          </a:p>
+        </p:txBody>
+      </p:sp>
+      <p:sp>
+        <p:nvSpPr>
+          <p:cNvPr id="28" name="Shape 25"/>
+          <p:cNvSpPr/>
+          <p:nvPr/>
+        </p:nvSpPr>
+        <p:spPr>
+          <a:xfrm>
+            <a:off x="640080" y="4297680"/>
+            <a:ext cx="7772400" cy="411480"/>
+          </a:xfrm>
+          <a:prstGeom prst="rect">
+            <a:avLst/>
+          </a:prstGeom>
+          <a:solidFill>
+            <a:srgbClr val="F1F5F9"/>
+          </a:solidFill>
+        </p:spPr>
+      </p:sp>
+      <p:sp>
+        <p:nvSpPr>
+          <p:cNvPr id="29" name="Text 26"/>
+          <p:cNvSpPr/>
+          <p:nvPr/>
+        </p:nvSpPr>
+        <p:spPr>
+          <a:xfrm>
+            <a:off x="777240" y="4297680"/>
+            <a:ext cx="7498080" cy="411480"/>
+          </a:xfrm>
+          <a:prstGeom prst="rect">
+            <a:avLst/>
+          </a:prstGeom>
+          <a:noFill/>
+        </p:spPr>
+        <p:txBody>
+          <a:bodyPr wrap="square" lIns="0" tIns="0" rIns="0" bIns="0" rtlCol="0" anchor="ctr"/>
+          <a:lstStyle/>
+          <a:p>
+            <a:pPr marL="0" indent="0">
+              <a:buNone/>
+            </a:pPr>
+            <a:r>
+              <a:rPr lang="en-US" sz="1200" dirty="0">
+                <a:solidFill>
+                  <a:srgbClr val="EC4899"/>
+                </a:solidFill>
+                <a:latin typeface="Consolas" pitchFamily="34" charset="0"/>
+                <a:ea typeface="Consolas" pitchFamily="34" charset="-122"/>
+                <a:cs typeface="Consolas" pitchFamily="34" charset="-120"/>
+              </a:rPr>
+              <a:t>→ docs/knowledge/  |  AGENTS.md + system-context + container-architecture + modules/ ×5 + flows/ ×5 + decisions/ ×3 + crosscutting/</a:t>
+            </a:r>
+            <a:endParaRPr lang="en-US" sz="1200" dirty="0"/>
           </a:p>
         </p:txBody>
       </p:sp>
@@ -12398,7 +13237,7 @@
                 <a:ea typeface="Consolas" pitchFamily="34" charset="-122"/>
                 <a:cs typeface="Consolas" pitchFamily="34" charset="-120"/>
               </a:rPr>
-              <a:t>docs/adr/NNNN-title.md</a:t>
+              <a:t>docs/knowledge/decisions/NNNN-title.md</a:t>
             </a:r>
             <a:endParaRPr lang="en-US" sz="950" dirty="0"/>
           </a:p>
@@ -12778,7 +13617,7 @@
                 <a:ea typeface="Consolas" pitchFamily="34" charset="-122"/>
                 <a:cs typeface="Consolas" pitchFamily="34" charset="-120"/>
               </a:rPr>
-              <a:t>GRAPH.md</a:t>
+              <a:t>knowledge/AGENTS.md</a:t>
             </a:r>
             <a:endParaRPr lang="en-US" sz="950" dirty="0"/>
           </a:p>
@@ -12816,7 +13655,7 @@
                 <a:ea typeface="Calibri" pitchFamily="34" charset="-122"/>
                 <a:cs typeface="Calibri" pitchFamily="34" charset="-120"/>
               </a:rPr>
-              <a:t>文本化关系图。改 A 会影响 B/C/D，因为...</a:t>
+              <a:t>Mermaid C4 + 模块蓝图 + 流程时序 + ADR 决策。结构化可视化知识</a:t>
             </a:r>
             <a:endParaRPr lang="en-US" sz="1000" dirty="0"/>
           </a:p>
@@ -13026,7 +13865,7 @@
                 <a:ea typeface="Calibri" pitchFamily="34" charset="-122"/>
                 <a:cs typeface="Calibri" pitchFamily="34" charset="-120"/>
               </a:rPr>
-              <a:t>5 阶段渐进式文档合成管线 — 每阶段确认后推进，不跳步不覆盖</a:t>
+              <a:t>7 阶段渐进式文档合成管线 — 每阶段确认后推进，不跳步不覆盖</a:t>
             </a:r>
             <a:endParaRPr lang="en-US" sz="1400" dirty="0"/>
           </a:p>
@@ -14442,7 +15281,7 @@
                 <a:ea typeface="Calibri" pitchFamily="34" charset="-122"/>
                 <a:cs typeface="Calibri" pitchFamily="34" charset="-120"/>
               </a:rPr>
-              <a:t>aidoc-create — 主流程编排器，一键串联 Phase 0–5</a:t>
+              <a:t>aidoc-build — 主流程编排器，一键串联 Phase 0–6</a:t>
             </a:r>
             <a:endParaRPr lang="en-US" sz="1400" dirty="0"/>
           </a:p>

</xml_diff>